<commit_message>
Connect automatic extraction to the review workspace and submission
</commit_message>
<xml_diff>
--- a/presentation/lawdiff-pitch.pptx
+++ b/presentation/lawdiff-pitch.pptx
@@ -2,14 +2,14 @@
 <file path=ppt/presentation.xml><?xml version="1.0" encoding="utf-8"?>
 <p:presentation xmlns:p="http://schemas.openxmlformats.org/presentationml/2006/main">
   <p:sldMasterIdLst>
-    <p:sldMasterId xmlns:r="http://schemas.openxmlformats.org/officeDocument/2006/relationships" id="2147483648" r:id="R91f120469ec744d3"/>
+    <p:sldMasterId xmlns:r="http://schemas.openxmlformats.org/officeDocument/2006/relationships" id="2147483648" r:id="R57c80efaec2e4e85"/>
   </p:sldMasterIdLst>
   <p:notesMasterIdLst>
-    <p:notesMasterId xmlns:r="http://schemas.openxmlformats.org/officeDocument/2006/relationships" r:id="R9c89c8f3298447e0"/>
+    <p:notesMasterId xmlns:r="http://schemas.openxmlformats.org/officeDocument/2006/relationships" r:id="Rd5ed4e33eb194212"/>
   </p:notesMasterIdLst>
   <p:sldIdLst>
-    <p:sldId xmlns:r="http://schemas.openxmlformats.org/officeDocument/2006/relationships" id="256" r:id="R271e302128ca40e7"/>
-    <p:sldId xmlns:r="http://schemas.openxmlformats.org/officeDocument/2006/relationships" id="257" r:id="R80f1cc5afbd04acf"/>
+    <p:sldId xmlns:r="http://schemas.openxmlformats.org/officeDocument/2006/relationships" id="256" r:id="R480e88f4df1a4c70"/>
+    <p:sldId xmlns:r="http://schemas.openxmlformats.org/officeDocument/2006/relationships" id="257" r:id="R8069bd40c08c4128"/>
   </p:sldIdLst>
   <p:sldSz cx="12192000" cy="6858000"/>
   <p:notesSz cx="6858000" cy="9144000"/>
@@ -443,7 +443,7 @@
           <a:lstStyle xmlns:a="http://schemas.openxmlformats.org/drawingml/2006/main"/>
           <a:p xmlns:a="http://schemas.openxmlformats.org/drawingml/2006/main">
             <a:r>
-              <a:t>A housing rule changes. Someone then has to connect a legal text to a portfolio: which buildings matter, which date matters, and which facts are missing? LawDiff brings that review into one workspace.</a:t>
+              <a:t>When a housing law changes, someone has to turn it into work. Which buildings need review? What evidence is missing? Who needs the source behind the answer?</a:t>
             </a:r>
           </a:p>
           <a:p xmlns:a="http://schemas.openxmlformats.org/drawingml/2006/main">
@@ -453,7 +453,7 @@
           </a:p>
           <a:p xmlns:a="http://schemas.openxmlformats.org/drawingml/2006/main">
             <a:r>
-              <a:t>Each mark is one address in the supplied sample. Here is New Jersey’s FAIR Act. It has been enacted, but on this date it is not yet effective. Move to July 2027. The extracted statewide rule now covers the 140 New Jersey addresses. That means the rule belongs in their review, not that any owner has violated it. The original passage stays one click away.</a:t>
+              <a:t>LawDiff connects those questions.</a:t>
             </a:r>
           </a:p>
           <a:p xmlns:a="http://schemas.openxmlformats.org/drawingml/2006/main">
@@ -463,7 +463,7 @@
           </a:p>
           <a:p xmlns:a="http://schemas.openxmlformats.org/drawingml/2006/main">
             <a:r>
-              <a:t>Now a separate Los Angeles case. This building was constructed in 1978. The year alone cannot establish the exact occupancy-date condition. LawDiff shows the condition and the missing evidence together. I add a hypothetical date, visibly labeled as a simulation. That branch resolves. Other exemption questions remain unknown. The rights card shares the original-data answer and sources, while keeping my simulation out of the shared result.</a:t>
+              <a:t>Here is New Jersey's FAIR Act before its operative date. Move past July first, twenty twenty-seven. One hundred forty supplied addresses now need a scope review. We do not assume that an apartment record proves every legal exception.</a:t>
             </a:r>
           </a:p>
           <a:p xmlns:a="http://schemas.openxmlformats.org/drawingml/2006/main">
@@ -473,7 +473,27 @@
           </a:p>
           <a:p xmlns:a="http://schemas.openxmlformats.org/drawingml/2006/main">
             <a:r>
-              <a:t>Sources: public/data/catalog.json (500 supplied addresses: CA250, NJ140, MA110); public/data/rule-pack.json and changes T3; D069 https://pub.njleg.state.nj.us/Bills/2026/AL26/43_.HTM. Each plotted mark represents one supplied address. Positions are illustrative groupings, not geographic coordinates. Blue means the extracted statewide rule is in scope on July2,2027, not a finding that an owner violated it. The LA certificate input in the live demo is a visibly labeled simulation that resolves one branch only. Speaker flow is designed to switch from this slide to the live app.</a:t>
+              <a:t>Open one building. The requirement, date and captured passage are linked. The trace identifies the missing primary-residence and institutional-use facts. A source quotation makes the interpretation inspectable; it does not certify it.</a:t>
+            </a:r>
+          </a:p>
+          <a:p xmlns:a="http://schemas.openxmlformats.org/drawingml/2006/main">
+            <a:r>
+              <a:t/>
+            </a:r>
+          </a:p>
+          <a:p xmlns:a="http://schemas.openxmlformats.org/drawingml/2006/main">
+            <a:r>
+              <a:t>Now create a review brief. Every listed address gets its status, evidence and next check. Export the original-data worklist for a compliance team. A legal change has become a concrete review task.</a:t>
+            </a:r>
+          </a:p>
+          <a:p xmlns:a="http://schemas.openxmlformats.org/drawingml/2006/main">
+            <a:r>
+              <a:t/>
+            </a:r>
+          </a:p>
+          <a:p xmlns:a="http://schemas.openxmlformats.org/drawingml/2006/main">
+            <a:r>
+              <a:t>Sources: public/data/catalog.json (500 supplied addresses: CA250, NJ140, MA110); public/data/rule-pack.json and changes T3; D069 https://pub.njleg.state.nj.us/Bills/2026/AL26/43_.HTM. Each plotted mark represents one supplied address. Positions are illustrative groupings, not geographic coordinates. Amber means that primary-residence and institutional-use facts are missing for the NJscope decision on July2,2027. It does not mean a violation or an established scope match. No LA simulation is included in this pitch. Speaker flow is designed to switch from this slide to the live app.</a:t>
             </a:r>
           </a:p>
         </p:txBody>
@@ -543,7 +563,7 @@
           <a:lstStyle xmlns:a="http://schemas.openxmlformats.org/drawingml/2006/main"/>
           <a:p xmlns:a="http://schemas.openxmlformats.org/drawingml/2006/main">
             <a:r>
-              <a:t>The technical foundation separates interpretation from execution. Codex extracted structured candidates from supplied source text. A shared engine runs the same conditions in the browser and the submission exports. Source checks and targeted tests catch specific errors; they do not certify the legal interpretation. Missing sources and unresolved geographic matches stay visible. We report internal test results without inventing an official score.</a:t>
+              <a:t>The technical foundation is one traceable pipeline. Recorded model calls extract candidates. An explicit review selects unchanged records. One deterministic engine serves the interface and submission files, without a model call at query time.</a:t>
             </a:r>
           </a:p>
           <a:p xmlns:a="http://schemas.openxmlformats.org/drawingml/2006/main">
@@ -553,7 +573,7 @@
           </a:p>
           <a:p xmlns:a="http://schemas.openxmlformats.org/drawingml/2006/main">
             <a:r>
-              <a:t>Our buyer hypothesis is a compliance team or property-software provider handling buildings across multiple jurisdictions. The first commercial scope would be narrow: reviewed changes for a defined portfolio, delivered as an integration and a review queue. We have not yet validated customer demand or pricing.</a:t>
+              <a:t>The selected pack contains eighty-nine records. Thirteen have executable conditions; seventy-six retain narrative coverage that needs interpretation review. Missing sources and rejected runs remain visible. That is our current boundary, not a claim of complete legal coverage.</a:t>
             </a:r>
           </a:p>
           <a:p xmlns:a="http://schemas.openxmlformats.org/drawingml/2006/main">
@@ -563,7 +583,7 @@
           </a:p>
           <a:p xmlns:a="http://schemas.openxmlformats.org/drawingml/2006/main">
             <a:r>
-              <a:t>The next milestone is an expert-reviewed pilot. We would measure missed applicable rules, unsupported conclusions, time needed to resolve an open case, and whether the customer would pay for the workflow. Expansion comes after that evidence.</a:t>
+              <a:t>Our first buyer hypothesis is a residential portfolio's compliance lead, working with a legal reviewer. The next step is a paid, thirty-day pilot in one jurisdiction, compared with today's process and existing software. We would measure review time, missed cases, unnecessary alerts and whether the team keeps using it.</a:t>
             </a:r>
           </a:p>
           <a:p xmlns:a="http://schemas.openxmlformats.org/drawingml/2006/main">
@@ -573,7 +593,7 @@
           </a:p>
           <a:p xmlns:a="http://schemas.openxmlformats.org/drawingml/2006/main">
             <a:r>
-              <a:t>LawDiff makes one promise you can inspect: see the change, follow the source, and understand what is still missing.</a:t>
+              <a:t>We have no paid customers or validated savings yet. The ambition is a reliable review workflow that grows without growing expert effort at the same rate.</a:t>
             </a:r>
           </a:p>
           <a:p xmlns:a="http://schemas.openxmlformats.org/drawingml/2006/main">
@@ -583,7 +603,17 @@
           </a:p>
           <a:p xmlns:a="http://schemas.openxmlformats.org/drawingml/2006/main">
             <a:r>
-              <a:t>Sources: public/data/rule-pack.json, public/data/catalog.json, source-span validation and internal test artifacts from the October4,2026 build. The58 records include one failed proposal labeled organizer_test_status and sourced to O001 (organizer dev/change_tests.json), not an independently acquired court record. The193 count is exact primary plus supplemental quotation matches. Geographic matches are Census/TIGER-derived matches and are not a measured accuracy percentage. The rule candidates are Codex-assisted; do not claim an external API extraction unless an actual run log supports that statement. Buyer, API offering, pilot and pricing are hypotheses, not current customers or validated demand. No claim of organizational endorsement from Studieren ohne Grenzen. Exact quotations support review; they do not certify interpretation. Public demo: https://yatrinn.github.io/lawdiff/ . Public repository: https://github.com/yatrinn/lawdiff .</a:t>
+              <a:t>LawDiff. When the law changes, see what needs review—and why.</a:t>
+            </a:r>
+          </a:p>
+          <a:p xmlns:a="http://schemas.openxmlformats.org/drawingml/2006/main">
+            <a:r>
+              <a:t/>
+            </a:r>
+          </a:p>
+          <a:p xmlns:a="http://schemas.openxmlformats.org/drawingml/2006/main">
+            <a:r>
+              <a:t>Sources: public/data/rule-pack.json, public/data/catalog.json, source-span validation and internal test artifacts from the October4,2026 build. The89 selected automatic records retain their original output hashes and rule objects. Thirteen coverage definitions are executable;76 remain narrative and require interpretation review. All89 primary quotations match the captured text. T1/T4pass qualitative organizer expectations;T2/T3/T5remain partial. No failed-status record is injected. Geographic matches are Census/TIGER-derived matches and are not a measured accuracy percentage. The selected records were generated by recorded tool-free Codex CLI calls and selected unchanged after AI-assisted source review. No independent legal review is claimed. Buyer, API offering, pilot and pricing are hypotheses, not current customers or validated demand. No claim of organizational endorsement from Studieren ohne Grenzen. Exact quotations support review; they do not certify interpretation. Public demo: https://yatrinn.github.io/lawdiff/ . Public repository: https://github.com/yatrinn/lawdiff .</a:t>
             </a:r>
           </a:p>
         </p:txBody>
@@ -651,7 +681,7 @@
   </p:cSld>
   <p:clrMap bg1="lt1" tx1="dk1" bg2="lt2" tx2="dk2" accent1="accent1" accent2="accent2" accent3="accent3" accent4="accent4" accent5="accent5" accent6="accent6" hlink="hlink" folHlink="folHlink"/>
   <p:sldLayoutIdLst>
-    <p:sldLayoutId xmlns:r="http://schemas.openxmlformats.org/officeDocument/2006/relationships" id="2147483649" r:id="Rdef69b69a8bf4a44"/>
+    <p:sldLayoutId xmlns:r="http://schemas.openxmlformats.org/officeDocument/2006/relationships" id="2147483649" r:id="R6e8f3472cb5747c5"/>
   </p:sldLayoutIdLst>
   <p:txStyles>
     <p:titleStyle>
@@ -2733,7 +2763,7 @@
           </c:tx>
           <c:spPr>
             <a:solidFill xmlns:a="http://schemas.openxmlformats.org/drawingml/2006/main">
-              <a:srgbClr val="155DE9"/>
+              <a:srgbClr val="A87512"/>
             </a:solidFill>
             <a:ln xmlns:a="http://schemas.openxmlformats.org/drawingml/2006/main" w="0">
               <a:noFill/>
@@ -4447,7 +4477,7 @@
           <p:cNvPr id="20" name="text">
             <a:extLst xmlns:a="http://schemas.openxmlformats.org/drawingml/2006/main">
               <a:ext uri="{FF2B5EF4-FFF2-40B4-BE49-F238E27FC236}">
-                <a16:creationId xmlns:a16="http://schemas.microsoft.com/office/drawing/2014/main" id="{D3FD6BB5-1C5D-4808-BF14-C7730BA51303}"/>
+                <a16:creationId xmlns:a16="http://schemas.microsoft.com/office/drawing/2014/main" id="{C73048A2-8DF2-4E3C-AB83-C3FD4B1DA6D0}"/>
               </a:ext>
             </a:extLst>
           </p:cNvPr>
@@ -4504,7 +4534,7 @@
           <p:cNvPr id="2" name="text">
             <a:extLst xmlns:a="http://schemas.openxmlformats.org/drawingml/2006/main">
               <a:ext uri="{FF2B5EF4-FFF2-40B4-BE49-F238E27FC236}">
-                <a16:creationId xmlns:a16="http://schemas.microsoft.com/office/drawing/2014/main" id="{65FCA2DA-259D-4205-9879-882C636A698D}"/>
+                <a16:creationId xmlns:a16="http://schemas.microsoft.com/office/drawing/2014/main" id="{4C4397C6-2B1A-46E2-9322-70DFA35208FC}"/>
               </a:ext>
             </a:extLst>
           </p:cNvPr>
@@ -4561,7 +4591,7 @@
           <p:cNvPr id="3" name="text">
             <a:extLst xmlns:a="http://schemas.openxmlformats.org/drawingml/2006/main">
               <a:ext uri="{FF2B5EF4-FFF2-40B4-BE49-F238E27FC236}">
-                <a16:creationId xmlns:a16="http://schemas.microsoft.com/office/drawing/2014/main" id="{24F50159-B49A-4285-885F-694235C23372}"/>
+                <a16:creationId xmlns:a16="http://schemas.microsoft.com/office/drawing/2014/main" id="{AC472C79-4A6E-4500-BC6B-C4F497A1CEC6}"/>
               </a:ext>
             </a:extLst>
           </p:cNvPr>
@@ -4618,7 +4648,7 @@
           <p:cNvPr id="4" name="main-title">
             <a:extLst xmlns:a="http://schemas.openxmlformats.org/drawingml/2006/main">
               <a:ext uri="{FF2B5EF4-FFF2-40B4-BE49-F238E27FC236}">
-                <a16:creationId xmlns:a16="http://schemas.microsoft.com/office/drawing/2014/main" id="{7C69FD2A-B17F-4E16-A9AA-3FB568FE7FEB}"/>
+                <a16:creationId xmlns:a16="http://schemas.microsoft.com/office/drawing/2014/main" id="{5315D7EA-D901-445A-A2A4-3D7997A3F934}"/>
               </a:ext>
             </a:extLst>
           </p:cNvPr>
@@ -4688,7 +4718,7 @@
                 <a:ea typeface="Helvetica Neue"/>
                 <a:cs typeface="Helvetica Neue"/>
               </a:rPr>
-              <a:t>See what follows.</a:t>
+              <a:t>What needs review?</a:t>
             </a:r>
           </a:p>
         </p:txBody>
@@ -4698,7 +4728,7 @@
           <p:cNvPr id="5" name="text">
             <a:extLst xmlns:a="http://schemas.openxmlformats.org/drawingml/2006/main">
               <a:ext uri="{FF2B5EF4-FFF2-40B4-BE49-F238E27FC236}">
-                <a16:creationId xmlns:a16="http://schemas.microsoft.com/office/drawing/2014/main" id="{21FD4C15-5BB1-4F78-BC2D-41FF50269E08}"/>
+                <a16:creationId xmlns:a16="http://schemas.microsoft.com/office/drawing/2014/main" id="{ED1BC634-6850-45AE-9F61-6EB8938C1B9E}"/>
               </a:ext>
             </a:extLst>
           </p:cNvPr>
@@ -4755,7 +4785,7 @@
           <p:cNvPr id="6" name="text">
             <a:extLst xmlns:a="http://schemas.openxmlformats.org/drawingml/2006/main">
               <a:ext uri="{FF2B5EF4-FFF2-40B4-BE49-F238E27FC236}">
-                <a16:creationId xmlns:a16="http://schemas.microsoft.com/office/drawing/2014/main" id="{FC085C14-FE32-4817-8C58-1388FD60922D}"/>
+                <a16:creationId xmlns:a16="http://schemas.microsoft.com/office/drawing/2014/main" id="{00D11EDA-9D22-4DC7-871F-FC6CA8246E56}"/>
               </a:ext>
             </a:extLst>
           </p:cNvPr>
@@ -4786,7 +4816,7 @@
             <a:pPr algn="l">
               <a:defRPr sz="7650" b="1">
                 <a:solidFill>
-                  <a:srgbClr val="155DE9"/>
+                  <a:srgbClr val="A87512"/>
                 </a:solidFill>
                 <a:latin typeface="Helvetica Neue"/>
                 <a:ea typeface="Helvetica Neue"/>
@@ -4796,7 +4826,7 @@
             <a:r>
               <a:rPr sz="7650" b="1">
                 <a:solidFill>
-                  <a:srgbClr val="155DE9"/>
+                  <a:srgbClr val="A87512"/>
                 </a:solidFill>
                 <a:latin typeface="Helvetica Neue"/>
                 <a:ea typeface="Helvetica Neue"/>
@@ -4812,7 +4842,7 @@
           <p:cNvPr id="7" name="text">
             <a:extLst xmlns:a="http://schemas.openxmlformats.org/drawingml/2006/main">
               <a:ext uri="{FF2B5EF4-FFF2-40B4-BE49-F238E27FC236}">
-                <a16:creationId xmlns:a16="http://schemas.microsoft.com/office/drawing/2014/main" id="{3D7603CB-5C24-46B7-8EB8-5EBC51BE7959}"/>
+                <a16:creationId xmlns:a16="http://schemas.microsoft.com/office/drawing/2014/main" id="{05FD45C5-1E73-41E6-8218-716D881D5B33}"/>
               </a:ext>
             </a:extLst>
           </p:cNvPr>
@@ -4859,7 +4889,7 @@
                 <a:ea typeface="Helvetica Neue"/>
                 <a:cs typeface="Helvetica Neue"/>
               </a:rPr>
-              <a:t>addresses in the</a:t>
+              <a:t>addresses needing</a:t>
             </a:r>
           </a:p>
           <a:p xmlns:a="http://schemas.openxmlformats.org/drawingml/2006/main">
@@ -4882,7 +4912,7 @@
                 <a:ea typeface="Helvetica Neue"/>
                 <a:cs typeface="Helvetica Neue"/>
               </a:rPr>
-              <a:t>statewide rule’s scope</a:t>
+              <a:t>scope evidence</a:t>
             </a:r>
           </a:p>
         </p:txBody>
@@ -4892,7 +4922,7 @@
           <p:cNvPr id="8" name="text">
             <a:extLst xmlns:a="http://schemas.openxmlformats.org/drawingml/2006/main">
               <a:ext uri="{FF2B5EF4-FFF2-40B4-BE49-F238E27FC236}">
-                <a16:creationId xmlns:a16="http://schemas.microsoft.com/office/drawing/2014/main" id="{8001F159-48EA-4FAA-B3E2-0EC8C8E1FE6D}"/>
+                <a16:creationId xmlns:a16="http://schemas.microsoft.com/office/drawing/2014/main" id="{79DF8DF4-EA77-4C4B-8AEE-A0B4885580E2}"/>
               </a:ext>
             </a:extLst>
           </p:cNvPr>
@@ -4956,7 +4986,7 @@
         </p:xfrm>
         <a:graphic xmlns:a="http://schemas.openxmlformats.org/drawingml/2006/main">
           <a:graphicData uri="http://schemas.openxmlformats.org/drawingml/2006/chart">
-            <c:chart xmlns:r="http://schemas.openxmlformats.org/officeDocument/2006/relationships" xmlns:c="http://schemas.openxmlformats.org/drawingml/2006/chart" r:id="R2034ad6efb974a72"/>
+            <c:chart xmlns:r="http://schemas.openxmlformats.org/officeDocument/2006/relationships" xmlns:c="http://schemas.openxmlformats.org/drawingml/2006/chart" r:id="Rb318a5308283490d"/>
           </a:graphicData>
         </a:graphic>
       </p:graphicFrame>
@@ -4965,7 +4995,7 @@
           <p:cNvPr id="10" name="text">
             <a:extLst xmlns:a="http://schemas.openxmlformats.org/drawingml/2006/main">
               <a:ext uri="{FF2B5EF4-FFF2-40B4-BE49-F238E27FC236}">
-                <a16:creationId xmlns:a16="http://schemas.microsoft.com/office/drawing/2014/main" id="{7E9F512D-EB3B-4974-B579-B07DB09824F6}"/>
+                <a16:creationId xmlns:a16="http://schemas.microsoft.com/office/drawing/2014/main" id="{282228DD-3BF3-42AB-A1E7-CFBE4B051360}"/>
               </a:ext>
             </a:extLst>
           </p:cNvPr>
@@ -5022,7 +5052,7 @@
           <p:cNvPr id="11" name="text">
             <a:extLst xmlns:a="http://schemas.openxmlformats.org/drawingml/2006/main">
               <a:ext uri="{FF2B5EF4-FFF2-40B4-BE49-F238E27FC236}">
-                <a16:creationId xmlns:a16="http://schemas.microsoft.com/office/drawing/2014/main" id="{ADD60667-58F5-441D-8439-BE313735D7C4}"/>
+                <a16:creationId xmlns:a16="http://schemas.microsoft.com/office/drawing/2014/main" id="{556F10DC-C831-4FD2-849B-A76DD9093C68}"/>
               </a:ext>
             </a:extLst>
           </p:cNvPr>
@@ -5053,7 +5083,7 @@
             <a:pPr algn="l">
               <a:defRPr sz="1500" b="1">
                 <a:solidFill>
-                  <a:srgbClr val="155DE9"/>
+                  <a:srgbClr val="A87512"/>
                 </a:solidFill>
                 <a:latin typeface="Helvetica Neue"/>
                 <a:ea typeface="Helvetica Neue"/>
@@ -5063,7 +5093,7 @@
             <a:r>
               <a:rPr sz="1500" b="1">
                 <a:solidFill>
-                  <a:srgbClr val="155DE9"/>
+                  <a:srgbClr val="A87512"/>
                 </a:solidFill>
                 <a:latin typeface="Helvetica Neue"/>
                 <a:ea typeface="Helvetica Neue"/>
@@ -5079,7 +5109,7 @@
           <p:cNvPr id="12" name="text">
             <a:extLst xmlns:a="http://schemas.openxmlformats.org/drawingml/2006/main">
               <a:ext uri="{FF2B5EF4-FFF2-40B4-BE49-F238E27FC236}">
-                <a16:creationId xmlns:a16="http://schemas.microsoft.com/office/drawing/2014/main" id="{9B4757EB-BA6E-4995-85B4-9C2833618E30}"/>
+                <a16:creationId xmlns:a16="http://schemas.microsoft.com/office/drawing/2014/main" id="{5E39CE0B-CD41-44EC-86C6-EFE9DE4BBE23}"/>
               </a:ext>
             </a:extLst>
           </p:cNvPr>
@@ -5136,7 +5166,7 @@
           <p:cNvPr id="13" name="text">
             <a:extLst xmlns:a="http://schemas.openxmlformats.org/drawingml/2006/main">
               <a:ext uri="{FF2B5EF4-FFF2-40B4-BE49-F238E27FC236}">
-                <a16:creationId xmlns:a16="http://schemas.microsoft.com/office/drawing/2014/main" id="{C9D25EFA-6645-4BE0-A2B9-9ADF0107F4EC}"/>
+                <a16:creationId xmlns:a16="http://schemas.microsoft.com/office/drawing/2014/main" id="{EB924975-2BAA-4E8A-8B7D-07BF28F3D790}"/>
               </a:ext>
             </a:extLst>
           </p:cNvPr>
@@ -5193,7 +5223,7 @@
           <p:cNvPr id="14" name="text">
             <a:extLst xmlns:a="http://schemas.openxmlformats.org/drawingml/2006/main">
               <a:ext uri="{FF2B5EF4-FFF2-40B4-BE49-F238E27FC236}">
-                <a16:creationId xmlns:a16="http://schemas.microsoft.com/office/drawing/2014/main" id="{B6721E95-BF9F-412F-8854-85E172BE82F5}"/>
+                <a16:creationId xmlns:a16="http://schemas.microsoft.com/office/drawing/2014/main" id="{8E366DE3-5DC6-4B4F-A140-C9C9298B27EA}"/>
               </a:ext>
             </a:extLst>
           </p:cNvPr>
@@ -5250,7 +5280,7 @@
           <p:cNvPr id="15" name="text">
             <a:extLst xmlns:a="http://schemas.openxmlformats.org/drawingml/2006/main">
               <a:ext uri="{FF2B5EF4-FFF2-40B4-BE49-F238E27FC236}">
-                <a16:creationId xmlns:a16="http://schemas.microsoft.com/office/drawing/2014/main" id="{892A4933-3E94-418E-AEC7-2197AF9723FA}"/>
+                <a16:creationId xmlns:a16="http://schemas.microsoft.com/office/drawing/2014/main" id="{2A23A450-3E14-47E4-8191-C9656625BBF3}"/>
               </a:ext>
             </a:extLst>
           </p:cNvPr>
@@ -5307,7 +5337,7 @@
           <p:cNvPr id="16" name="text">
             <a:extLst xmlns:a="http://schemas.openxmlformats.org/drawingml/2006/main">
               <a:ext uri="{FF2B5EF4-FFF2-40B4-BE49-F238E27FC236}">
-                <a16:creationId xmlns:a16="http://schemas.microsoft.com/office/drawing/2014/main" id="{CD8620A5-AE38-4669-BBC6-C839B27EA7C1}"/>
+                <a16:creationId xmlns:a16="http://schemas.microsoft.com/office/drawing/2014/main" id="{F483628F-91C7-4142-8764-8E58420CB0A0}"/>
               </a:ext>
             </a:extLst>
           </p:cNvPr>
@@ -5414,7 +5444,7 @@
           <p:cNvPr id="19" name="text">
             <a:extLst xmlns:a="http://schemas.openxmlformats.org/drawingml/2006/main">
               <a:ext uri="{FF2B5EF4-FFF2-40B4-BE49-F238E27FC236}">
-                <a16:creationId xmlns:a16="http://schemas.microsoft.com/office/drawing/2014/main" id="{18501F9F-E7CF-4B53-8898-0AF4808C0830}"/>
+                <a16:creationId xmlns:a16="http://schemas.microsoft.com/office/drawing/2014/main" id="{EFAAA08A-8919-4E9F-A23F-131D3964220A}"/>
               </a:ext>
             </a:extLst>
           </p:cNvPr>
@@ -5469,7 +5499,7 @@
     </p:spTree>
     <p:extLst>
       <p:ext uri="{BB962C8B-B14F-4D97-AF65-F5344CB8AC3E}">
-        <p14:creationId xmlns:p14="http://schemas.microsoft.com/office/powerpoint/2010/main" val="1309613037"/>
+        <p14:creationId xmlns:p14="http://schemas.microsoft.com/office/powerpoint/2010/main" val="356139482"/>
       </p:ext>
     </p:extLst>
   </p:cSld>
@@ -5500,7 +5530,7 @@
           <p:cNvPr id="33" name="text">
             <a:extLst xmlns:a="http://schemas.openxmlformats.org/drawingml/2006/main">
               <a:ext uri="{FF2B5EF4-FFF2-40B4-BE49-F238E27FC236}">
-                <a16:creationId xmlns:a16="http://schemas.microsoft.com/office/drawing/2014/main" id="{47CB1D33-D998-4CB5-9FD6-A5DAF787FCFF}"/>
+                <a16:creationId xmlns:a16="http://schemas.microsoft.com/office/drawing/2014/main" id="{EF7CACAB-6946-45F9-A656-6FA144EB16C8}"/>
               </a:ext>
             </a:extLst>
           </p:cNvPr>
@@ -5557,7 +5587,7 @@
           <p:cNvPr id="2" name="text">
             <a:extLst xmlns:a="http://schemas.openxmlformats.org/drawingml/2006/main">
               <a:ext uri="{FF2B5EF4-FFF2-40B4-BE49-F238E27FC236}">
-                <a16:creationId xmlns:a16="http://schemas.microsoft.com/office/drawing/2014/main" id="{E95D2885-850F-4011-99A7-CF9629C7CA61}"/>
+                <a16:creationId xmlns:a16="http://schemas.microsoft.com/office/drawing/2014/main" id="{0ECF3D50-F7B5-4849-9BEA-FD65F103349A}"/>
               </a:ext>
             </a:extLst>
           </p:cNvPr>
@@ -5614,7 +5644,7 @@
           <p:cNvPr id="3" name="text">
             <a:extLst xmlns:a="http://schemas.openxmlformats.org/drawingml/2006/main">
               <a:ext uri="{FF2B5EF4-FFF2-40B4-BE49-F238E27FC236}">
-                <a16:creationId xmlns:a16="http://schemas.microsoft.com/office/drawing/2014/main" id="{989728F0-51A8-4F98-820E-9F5C44DA20E5}"/>
+                <a16:creationId xmlns:a16="http://schemas.microsoft.com/office/drawing/2014/main" id="{2E647862-F4D0-4BBF-88CF-628376083959}"/>
               </a:ext>
             </a:extLst>
           </p:cNvPr>
@@ -5671,7 +5701,7 @@
           <p:cNvPr id="4" name="main-title">
             <a:extLst xmlns:a="http://schemas.openxmlformats.org/drawingml/2006/main">
               <a:ext uri="{FF2B5EF4-FFF2-40B4-BE49-F238E27FC236}">
-                <a16:creationId xmlns:a16="http://schemas.microsoft.com/office/drawing/2014/main" id="{AB8A0A38-792A-4C56-9763-3A60868B376B}"/>
+                <a16:creationId xmlns:a16="http://schemas.microsoft.com/office/drawing/2014/main" id="{65B45820-94D7-42E7-BDDA-CEF20DD1E1B7}"/>
               </a:ext>
             </a:extLst>
           </p:cNvPr>
@@ -5751,7 +5781,7 @@
           <p:cNvPr id="5" name="text">
             <a:extLst xmlns:a="http://schemas.openxmlformats.org/drawingml/2006/main">
               <a:ext uri="{FF2B5EF4-FFF2-40B4-BE49-F238E27FC236}">
-                <a16:creationId xmlns:a16="http://schemas.microsoft.com/office/drawing/2014/main" id="{5044CBDE-E8C2-4456-83BD-FA9C9B7BBB64}"/>
+                <a16:creationId xmlns:a16="http://schemas.microsoft.com/office/drawing/2014/main" id="{9777C886-90F4-4C45-8C11-54951A18F958}"/>
               </a:ext>
             </a:extLst>
           </p:cNvPr>
@@ -5808,7 +5838,7 @@
           <p:cNvPr id="6" name="text">
             <a:extLst xmlns:a="http://schemas.openxmlformats.org/drawingml/2006/main">
               <a:ext uri="{FF2B5EF4-FFF2-40B4-BE49-F238E27FC236}">
-                <a16:creationId xmlns:a16="http://schemas.microsoft.com/office/drawing/2014/main" id="{17E32504-216B-4738-A96D-3F86B6713E4C}"/>
+                <a16:creationId xmlns:a16="http://schemas.microsoft.com/office/drawing/2014/main" id="{C36CD957-28C8-4339-ADDC-040B41D94D24}"/>
               </a:ext>
             </a:extLst>
           </p:cNvPr>
@@ -5865,7 +5895,7 @@
           <p:cNvPr id="7" name="text">
             <a:extLst xmlns:a="http://schemas.openxmlformats.org/drawingml/2006/main">
               <a:ext uri="{FF2B5EF4-FFF2-40B4-BE49-F238E27FC236}">
-                <a16:creationId xmlns:a16="http://schemas.microsoft.com/office/drawing/2014/main" id="{5AE9ECFF-01A0-4672-B181-C2B66F7A829F}"/>
+                <a16:creationId xmlns:a16="http://schemas.microsoft.com/office/drawing/2014/main" id="{259006E4-FE06-4D5E-B513-04F39ADB465F}"/>
               </a:ext>
             </a:extLst>
           </p:cNvPr>
@@ -5922,7 +5952,7 @@
           <p:cNvPr id="8" name="text">
             <a:extLst xmlns:a="http://schemas.openxmlformats.org/drawingml/2006/main">
               <a:ext uri="{FF2B5EF4-FFF2-40B4-BE49-F238E27FC236}">
-                <a16:creationId xmlns:a16="http://schemas.microsoft.com/office/drawing/2014/main" id="{5C512B04-DDA9-4CE7-A9B3-348C7C9C83E0}"/>
+                <a16:creationId xmlns:a16="http://schemas.microsoft.com/office/drawing/2014/main" id="{599FB0D5-DEDB-46E7-8B38-8889E1937802}"/>
               </a:ext>
             </a:extLst>
           </p:cNvPr>
@@ -5979,7 +6009,7 @@
           <p:cNvPr id="9" name="text">
             <a:extLst xmlns:a="http://schemas.openxmlformats.org/drawingml/2006/main">
               <a:ext uri="{FF2B5EF4-FFF2-40B4-BE49-F238E27FC236}">
-                <a16:creationId xmlns:a16="http://schemas.microsoft.com/office/drawing/2014/main" id="{CEE9EC1B-13E9-4C0B-8348-05D7ABB13E39}"/>
+                <a16:creationId xmlns:a16="http://schemas.microsoft.com/office/drawing/2014/main" id="{18B7726E-84FE-4E82-A35E-B079CD0DFF86}"/>
               </a:ext>
             </a:extLst>
           </p:cNvPr>
@@ -6036,7 +6066,7 @@
           <p:cNvPr id="10" name="text">
             <a:extLst xmlns:a="http://schemas.openxmlformats.org/drawingml/2006/main">
               <a:ext uri="{FF2B5EF4-FFF2-40B4-BE49-F238E27FC236}">
-                <a16:creationId xmlns:a16="http://schemas.microsoft.com/office/drawing/2014/main" id="{FCC4B8CA-B354-4688-A979-07696F517CF2}"/>
+                <a16:creationId xmlns:a16="http://schemas.microsoft.com/office/drawing/2014/main" id="{F1229D03-6A5E-41D1-8530-60EBE6EDEE66}"/>
               </a:ext>
             </a:extLst>
           </p:cNvPr>
@@ -6083,7 +6113,7 @@
                 <a:ea typeface="Helvetica Neue"/>
                 <a:cs typeface="Helvetica Neue"/>
               </a:rPr>
-              <a:t>Codex-assisted extraction</a:t>
+              <a:t>Automatic + source review</a:t>
             </a:r>
           </a:p>
         </p:txBody>
@@ -6093,7 +6123,7 @@
           <p:cNvPr id="11" name="text">
             <a:extLst xmlns:a="http://schemas.openxmlformats.org/drawingml/2006/main">
               <a:ext uri="{FF2B5EF4-FFF2-40B4-BE49-F238E27FC236}">
-                <a16:creationId xmlns:a16="http://schemas.microsoft.com/office/drawing/2014/main" id="{002CBBB8-46F7-499E-A5B6-10CAA8175562}"/>
+                <a16:creationId xmlns:a16="http://schemas.microsoft.com/office/drawing/2014/main" id="{1D9DBCBE-DA98-4014-8D29-CB28CFAFD038}"/>
               </a:ext>
             </a:extLst>
           </p:cNvPr>
@@ -6150,7 +6180,7 @@
           <p:cNvPr id="12" name="text">
             <a:extLst xmlns:a="http://schemas.openxmlformats.org/drawingml/2006/main">
               <a:ext uri="{FF2B5EF4-FFF2-40B4-BE49-F238E27FC236}">
-                <a16:creationId xmlns:a16="http://schemas.microsoft.com/office/drawing/2014/main" id="{7692D4FA-23DF-4B43-A22D-E7A85E6B79B7}"/>
+                <a16:creationId xmlns:a16="http://schemas.microsoft.com/office/drawing/2014/main" id="{F257DE52-F622-4FFE-9905-59DB632A39F7}"/>
               </a:ext>
             </a:extLst>
           </p:cNvPr>
@@ -6207,7 +6237,7 @@
           <p:cNvPr id="13" name="text">
             <a:extLst xmlns:a="http://schemas.openxmlformats.org/drawingml/2006/main">
               <a:ext uri="{FF2B5EF4-FFF2-40B4-BE49-F238E27FC236}">
-                <a16:creationId xmlns:a16="http://schemas.microsoft.com/office/drawing/2014/main" id="{F82C014F-ECDB-4D5D-9AAD-128187DE1A45}"/>
+                <a16:creationId xmlns:a16="http://schemas.microsoft.com/office/drawing/2014/main" id="{829FDCC0-9ED2-4054-ABA9-2E84805A9797}"/>
               </a:ext>
             </a:extLst>
           </p:cNvPr>
@@ -6264,7 +6294,7 @@
           <p:cNvPr id="14" name="text">
             <a:extLst xmlns:a="http://schemas.openxmlformats.org/drawingml/2006/main">
               <a:ext uri="{FF2B5EF4-FFF2-40B4-BE49-F238E27FC236}">
-                <a16:creationId xmlns:a16="http://schemas.microsoft.com/office/drawing/2014/main" id="{40BA02B2-2E63-4BE0-B2FA-DFDAD30DEBCF}"/>
+                <a16:creationId xmlns:a16="http://schemas.microsoft.com/office/drawing/2014/main" id="{401A55E7-8EA5-49B2-9C1B-4F383420B69E}"/>
               </a:ext>
             </a:extLst>
           </p:cNvPr>
@@ -6321,7 +6351,7 @@
           <p:cNvPr id="15" name="text">
             <a:extLst xmlns:a="http://schemas.openxmlformats.org/drawingml/2006/main">
               <a:ext uri="{FF2B5EF4-FFF2-40B4-BE49-F238E27FC236}">
-                <a16:creationId xmlns:a16="http://schemas.microsoft.com/office/drawing/2014/main" id="{333464E2-4FF4-4C0E-8138-50335D1D1B39}"/>
+                <a16:creationId xmlns:a16="http://schemas.microsoft.com/office/drawing/2014/main" id="{CA1EE214-B021-40CB-AC18-D49CB4C82CBB}"/>
               </a:ext>
             </a:extLst>
           </p:cNvPr>
@@ -6378,7 +6408,7 @@
           <p:cNvPr id="16" name="text">
             <a:extLst xmlns:a="http://schemas.openxmlformats.org/drawingml/2006/main">
               <a:ext uri="{FF2B5EF4-FFF2-40B4-BE49-F238E27FC236}">
-                <a16:creationId xmlns:a16="http://schemas.microsoft.com/office/drawing/2014/main" id="{CC66E381-6559-4A8B-9CE3-D9257AF10198}"/>
+                <a16:creationId xmlns:a16="http://schemas.microsoft.com/office/drawing/2014/main" id="{97F02057-E718-4F57-99B3-AC03B9695F1B}"/>
               </a:ext>
             </a:extLst>
           </p:cNvPr>
@@ -6510,7 +6540,7 @@
           <p:cNvPr id="20" name="text">
             <a:extLst xmlns:a="http://schemas.openxmlformats.org/drawingml/2006/main">
               <a:ext uri="{FF2B5EF4-FFF2-40B4-BE49-F238E27FC236}">
-                <a16:creationId xmlns:a16="http://schemas.microsoft.com/office/drawing/2014/main" id="{07BA8D36-43B1-419F-A8A6-11EB53EE60C1}"/>
+                <a16:creationId xmlns:a16="http://schemas.microsoft.com/office/drawing/2014/main" id="{F70210AD-2886-458A-BCFB-41CE98083E05}"/>
               </a:ext>
             </a:extLst>
           </p:cNvPr>
@@ -6557,7 +6587,7 @@
                 <a:ea typeface="Helvetica Neue"/>
                 <a:cs typeface="Helvetica Neue"/>
               </a:rPr>
-              <a:t>58</a:t>
+              <a:t>89</a:t>
             </a:r>
           </a:p>
         </p:txBody>
@@ -6567,7 +6597,7 @@
           <p:cNvPr id="21" name="text">
             <a:extLst xmlns:a="http://schemas.openxmlformats.org/drawingml/2006/main">
               <a:ext uri="{FF2B5EF4-FFF2-40B4-BE49-F238E27FC236}">
-                <a16:creationId xmlns:a16="http://schemas.microsoft.com/office/drawing/2014/main" id="{53014566-D464-4E88-93F1-4AF9C2C6021B}"/>
+                <a16:creationId xmlns:a16="http://schemas.microsoft.com/office/drawing/2014/main" id="{6817118C-52D6-4C7D-9F0D-C96C34B3F928}"/>
               </a:ext>
             </a:extLst>
           </p:cNvPr>
@@ -6614,7 +6644,7 @@
                 <a:ea typeface="Helvetica Neue"/>
                 <a:cs typeface="Helvetica Neue"/>
               </a:rPr>
-              <a:t>rule / status records</a:t>
+              <a:t>selected rule records</a:t>
             </a:r>
           </a:p>
         </p:txBody>
@@ -6624,7 +6654,7 @@
           <p:cNvPr id="22" name="text">
             <a:extLst xmlns:a="http://schemas.openxmlformats.org/drawingml/2006/main">
               <a:ext uri="{FF2B5EF4-FFF2-40B4-BE49-F238E27FC236}">
-                <a16:creationId xmlns:a16="http://schemas.microsoft.com/office/drawing/2014/main" id="{E04E3A37-6DC4-4830-9AB8-BB7A1C4ED867}"/>
+                <a16:creationId xmlns:a16="http://schemas.microsoft.com/office/drawing/2014/main" id="{426A8454-1576-4A35-A2C3-405D4B61AFE1}"/>
               </a:ext>
             </a:extLst>
           </p:cNvPr>
@@ -6671,7 +6701,7 @@
                 <a:ea typeface="Helvetica Neue"/>
                 <a:cs typeface="Helvetica Neue"/>
               </a:rPr>
-              <a:t>193</a:t>
+              <a:t>13</a:t>
             </a:r>
           </a:p>
         </p:txBody>
@@ -6681,7 +6711,7 @@
           <p:cNvPr id="23" name="text">
             <a:extLst xmlns:a="http://schemas.openxmlformats.org/drawingml/2006/main">
               <a:ext uri="{FF2B5EF4-FFF2-40B4-BE49-F238E27FC236}">
-                <a16:creationId xmlns:a16="http://schemas.microsoft.com/office/drawing/2014/main" id="{9653870B-F8C1-47AB-9ED7-E1C7AD5FD5C2}"/>
+                <a16:creationId xmlns:a16="http://schemas.microsoft.com/office/drawing/2014/main" id="{F369DFAB-EA0F-4622-86CE-D892588FCB39}"/>
               </a:ext>
             </a:extLst>
           </p:cNvPr>
@@ -6728,7 +6758,7 @@
                 <a:ea typeface="Helvetica Neue"/>
                 <a:cs typeface="Helvetica Neue"/>
               </a:rPr>
-              <a:t>checked quotation spans</a:t>
+              <a:t>executable coverage</a:t>
             </a:r>
           </a:p>
         </p:txBody>
@@ -6738,7 +6768,7 @@
           <p:cNvPr id="24" name="text">
             <a:extLst xmlns:a="http://schemas.openxmlformats.org/drawingml/2006/main">
               <a:ext uri="{FF2B5EF4-FFF2-40B4-BE49-F238E27FC236}">
-                <a16:creationId xmlns:a16="http://schemas.microsoft.com/office/drawing/2014/main" id="{BB31071E-CCAE-4F9C-9A6B-1D766BBC2146}"/>
+                <a16:creationId xmlns:a16="http://schemas.microsoft.com/office/drawing/2014/main" id="{C1B17FD6-479C-407A-B869-709A6B37DF79}"/>
               </a:ext>
             </a:extLst>
           </p:cNvPr>
@@ -6795,7 +6825,7 @@
           <p:cNvPr id="25" name="text">
             <a:extLst xmlns:a="http://schemas.openxmlformats.org/drawingml/2006/main">
               <a:ext uri="{FF2B5EF4-FFF2-40B4-BE49-F238E27FC236}">
-                <a16:creationId xmlns:a16="http://schemas.microsoft.com/office/drawing/2014/main" id="{525A6177-C941-4DDD-8F9C-73704C7BAA67}"/>
+                <a16:creationId xmlns:a16="http://schemas.microsoft.com/office/drawing/2014/main" id="{C71BBD63-A613-4D46-BCC6-08C2EA71AFA8}"/>
               </a:ext>
             </a:extLst>
           </p:cNvPr>
@@ -6852,7 +6882,7 @@
           <p:cNvPr id="26" name="text">
             <a:extLst xmlns:a="http://schemas.openxmlformats.org/drawingml/2006/main">
               <a:ext uri="{FF2B5EF4-FFF2-40B4-BE49-F238E27FC236}">
-                <a16:creationId xmlns:a16="http://schemas.microsoft.com/office/drawing/2014/main" id="{13035B4E-DED4-4440-87E7-1D7D58096E2A}"/>
+                <a16:creationId xmlns:a16="http://schemas.microsoft.com/office/drawing/2014/main" id="{AD4E9D0E-304A-462E-B93E-4AA7F76D90D5}"/>
               </a:ext>
             </a:extLst>
           </p:cNvPr>
@@ -6932,7 +6962,7 @@
           <p:cNvPr id="27" name="text">
             <a:extLst xmlns:a="http://schemas.openxmlformats.org/drawingml/2006/main">
               <a:ext uri="{FF2B5EF4-FFF2-40B4-BE49-F238E27FC236}">
-                <a16:creationId xmlns:a16="http://schemas.microsoft.com/office/drawing/2014/main" id="{A397A0F6-4AE6-46E4-8D49-12DE1C963BEB}"/>
+                <a16:creationId xmlns:a16="http://schemas.microsoft.com/office/drawing/2014/main" id="{3453297F-40C8-413B-8EAD-378C452F22B5}"/>
               </a:ext>
             </a:extLst>
           </p:cNvPr>
@@ -6989,7 +7019,7 @@
           <p:cNvPr id="28" name="text">
             <a:extLst xmlns:a="http://schemas.openxmlformats.org/drawingml/2006/main">
               <a:ext uri="{FF2B5EF4-FFF2-40B4-BE49-F238E27FC236}">
-                <a16:creationId xmlns:a16="http://schemas.microsoft.com/office/drawing/2014/main" id="{6A1B8D4F-B7DE-4AA1-AE0A-A30C6DC75565}"/>
+                <a16:creationId xmlns:a16="http://schemas.microsoft.com/office/drawing/2014/main" id="{1D3F7C6A-CDD1-46E1-ABD3-730A47E89A9A}"/>
               </a:ext>
             </a:extLst>
           </p:cNvPr>
@@ -7036,7 +7066,7 @@
                 <a:ea typeface="Helvetica Neue"/>
                 <a:cs typeface="Helvetica Neue"/>
               </a:rPr>
-              <a:t>Property compliance API</a:t>
+              <a:t>Portfolio review workflow</a:t>
             </a:r>
           </a:p>
         </p:txBody>
@@ -7046,7 +7076,7 @@
           <p:cNvPr id="29" name="text">
             <a:extLst xmlns:a="http://schemas.openxmlformats.org/drawingml/2006/main">
               <a:ext uri="{FF2B5EF4-FFF2-40B4-BE49-F238E27FC236}">
-                <a16:creationId xmlns:a16="http://schemas.microsoft.com/office/drawing/2014/main" id="{69041EA1-D8FE-4072-98CA-D759401FACB9}"/>
+                <a16:creationId xmlns:a16="http://schemas.microsoft.com/office/drawing/2014/main" id="{2F97D8CD-8671-43E0-8F08-BF5EC72E4197}"/>
               </a:ext>
             </a:extLst>
           </p:cNvPr>
@@ -7093,7 +7123,7 @@
                 <a:ea typeface="Helvetica Neue"/>
                 <a:cs typeface="Helvetica Neue"/>
               </a:rPr>
-              <a:t>Review queues for operators</a:t>
+              <a:t>Change → evidence → review</a:t>
             </a:r>
           </a:p>
           <a:p xmlns:a="http://schemas.openxmlformats.org/drawingml/2006/main">
@@ -7116,7 +7146,7 @@
                 <a:ea typeface="Helvetica Neue"/>
                 <a:cs typeface="Helvetica Neue"/>
               </a:rPr>
-              <a:t>Transparent cards for residents</a:t>
+              <a:t>30-day paid pilot proposed</a:t>
             </a:r>
           </a:p>
         </p:txBody>
@@ -7126,7 +7156,7 @@
           <p:cNvPr id="30" name="text">
             <a:extLst xmlns:a="http://schemas.openxmlformats.org/drawingml/2006/main">
               <a:ext uri="{FF2B5EF4-FFF2-40B4-BE49-F238E27FC236}">
-                <a16:creationId xmlns:a16="http://schemas.microsoft.com/office/drawing/2014/main" id="{1CA2C776-0402-4895-90F1-D2A1489CEEC4}"/>
+                <a16:creationId xmlns:a16="http://schemas.microsoft.com/office/drawing/2014/main" id="{C7B6694B-9139-4B0F-B5D6-ECC40884AD8D}"/>
               </a:ext>
             </a:extLst>
           </p:cNvPr>
@@ -7206,7 +7236,7 @@
           <p:cNvPr id="31" name="text">
             <a:extLst xmlns:a="http://schemas.openxmlformats.org/drawingml/2006/main">
               <a:ext uri="{FF2B5EF4-FFF2-40B4-BE49-F238E27FC236}">
-                <a16:creationId xmlns:a16="http://schemas.microsoft.com/office/drawing/2014/main" id="{9BFB9D58-1E2A-47EF-B0FE-18DD5156AB53}"/>
+                <a16:creationId xmlns:a16="http://schemas.microsoft.com/office/drawing/2014/main" id="{EE4253B9-5BBB-4F18-8094-DC4218B4D416}"/>
               </a:ext>
             </a:extLst>
           </p:cNvPr>
@@ -7263,7 +7293,7 @@
           <p:cNvPr id="32" name="text">
             <a:extLst xmlns:a="http://schemas.openxmlformats.org/drawingml/2006/main">
               <a:ext uri="{FF2B5EF4-FFF2-40B4-BE49-F238E27FC236}">
-                <a16:creationId xmlns:a16="http://schemas.microsoft.com/office/drawing/2014/main" id="{04BC1203-D2B3-4FCF-B3C3-B1C9DA04E74E}"/>
+                <a16:creationId xmlns:a16="http://schemas.microsoft.com/office/drawing/2014/main" id="{919BC6A1-2CC9-4237-A2D0-5378F3ED2A21}"/>
               </a:ext>
             </a:extLst>
           </p:cNvPr>
@@ -7318,7 +7348,7 @@
     </p:spTree>
     <p:extLst>
       <p:ext uri="{BB962C8B-B14F-4D97-AF65-F5344CB8AC3E}">
-        <p14:creationId xmlns:p14="http://schemas.microsoft.com/office/powerpoint/2010/main" val="644042407"/>
+        <p14:creationId xmlns:p14="http://schemas.microsoft.com/office/powerpoint/2010/main" val="1708594228"/>
       </p:ext>
     </p:extLst>
   </p:cSld>

</xml_diff>

<commit_message>
Finalize verified California coverage, geography and narrated submission assets
</commit_message>
<xml_diff>
--- a/presentation/lawdiff-pitch.pptx
+++ b/presentation/lawdiff-pitch.pptx
@@ -2,14 +2,14 @@
 <file path=ppt/presentation.xml><?xml version="1.0" encoding="utf-8"?>
 <p:presentation xmlns:p="http://schemas.openxmlformats.org/presentationml/2006/main">
   <p:sldMasterIdLst>
-    <p:sldMasterId xmlns:r="http://schemas.openxmlformats.org/officeDocument/2006/relationships" id="2147483648" r:id="R57c80efaec2e4e85"/>
+    <p:sldMasterId xmlns:r="http://schemas.openxmlformats.org/officeDocument/2006/relationships" id="2147483648" r:id="R80ec0960ad8342fa"/>
   </p:sldMasterIdLst>
   <p:notesMasterIdLst>
-    <p:notesMasterId xmlns:r="http://schemas.openxmlformats.org/officeDocument/2006/relationships" r:id="Rd5ed4e33eb194212"/>
+    <p:notesMasterId xmlns:r="http://schemas.openxmlformats.org/officeDocument/2006/relationships" r:id="R760418cc3730463f"/>
   </p:notesMasterIdLst>
   <p:sldIdLst>
-    <p:sldId xmlns:r="http://schemas.openxmlformats.org/officeDocument/2006/relationships" id="256" r:id="R480e88f4df1a4c70"/>
-    <p:sldId xmlns:r="http://schemas.openxmlformats.org/officeDocument/2006/relationships" id="257" r:id="R8069bd40c08c4128"/>
+    <p:sldId xmlns:r="http://schemas.openxmlformats.org/officeDocument/2006/relationships" id="256" r:id="Ra5f9e23a049a4094"/>
+    <p:sldId xmlns:r="http://schemas.openxmlformats.org/officeDocument/2006/relationships" id="257" r:id="Rc8c82ee05a4a4acd"/>
   </p:sldIdLst>
   <p:sldSz cx="12192000" cy="6858000"/>
   <p:notesSz cx="6858000" cy="9144000"/>
@@ -463,7 +463,7 @@
           </a:p>
           <a:p xmlns:a="http://schemas.openxmlformats.org/drawingml/2006/main">
             <a:r>
-              <a:t>Here is New Jersey's FAIR Act before its operative date. Move past July first, twenty twenty-seven. One hundred forty supplied addresses now need a scope review. We do not assume that an apartment record proves every legal exception.</a:t>
+              <a:t>Here is New Jersey's FAIR Act before its operative date. Move past July first, twenty twenty-seven. 140 supplied addresses now need a scope review. We do not assume that an apartment record proves every legal exception.</a:t>
             </a:r>
           </a:p>
           <a:p xmlns:a="http://schemas.openxmlformats.org/drawingml/2006/main">
@@ -493,7 +493,7 @@
           </a:p>
           <a:p xmlns:a="http://schemas.openxmlformats.org/drawingml/2006/main">
             <a:r>
-              <a:t>Sources: public/data/catalog.json (500 supplied addresses: CA250, NJ140, MA110); public/data/rule-pack.json and changes T3; D069 https://pub.njleg.state.nj.us/Bills/2026/AL26/43_.HTM. Each plotted mark represents one supplied address. Positions are illustrative groupings, not geographic coordinates. Amber means that primary-residence and institutional-use facts are missing for the NJscope decision on July2,2027. It does not mean a violation or an established scope match. No LA simulation is included in this pitch. Speaker flow is designed to switch from this slide to the live app.</a:t>
+              <a:t>Sources: public/data/catalog.json (500 supplied addresses: CA 250, NJ 140, MA 110); public/data/rule-pack.json and changes T3; D069 https://pub.njleg.state.nj.us/Bills/2026/AL26/43_.HTM. Each plotted mark represents one supplied address. Positions are illustrative groupings, not geographic coordinates. Amber means that primary-residence and institutional-use facts are missing for the NJscope decision on July2,2027. It does not mean a violation or an established scope match. No LA simulation is included in this pitch. Speaker flow is designed to switch from this slide to the live app.</a:t>
             </a:r>
           </a:p>
         </p:txBody>
@@ -573,7 +573,7 @@
           </a:p>
           <a:p xmlns:a="http://schemas.openxmlformats.org/drawingml/2006/main">
             <a:r>
-              <a:t>The selected pack contains eighty-nine records. Thirteen have executable conditions; seventy-six retain narrative coverage that needs interpretation review. Missing sources and rejected runs remain visible. That is our current boundary, not a claim of complete legal coverage.</a:t>
+              <a:t>The selected pack contains 133 unchanged automatic records. 22 have executable conditions; 111 retain narrative coverage that needs interpretation review. Census evidence establishes a legal city for 491 of 500 addresses. Missing sources and rejected runs remain visible. That is our current boundary, not a claim of complete legal coverage.</a:t>
             </a:r>
           </a:p>
           <a:p xmlns:a="http://schemas.openxmlformats.org/drawingml/2006/main">
@@ -603,7 +603,7 @@
           </a:p>
           <a:p xmlns:a="http://schemas.openxmlformats.org/drawingml/2006/main">
             <a:r>
-              <a:t>LawDiff. When the law changes, see what needs review—and why.</a:t>
+              <a:t>LawDiff. When the law changes, see what needs review, and why.</a:t>
             </a:r>
           </a:p>
           <a:p xmlns:a="http://schemas.openxmlformats.org/drawingml/2006/main">
@@ -613,7 +613,7 @@
           </a:p>
           <a:p xmlns:a="http://schemas.openxmlformats.org/drawingml/2006/main">
             <a:r>
-              <a:t>Sources: public/data/rule-pack.json, public/data/catalog.json, source-span validation and internal test artifacts from the October4,2026 build. The89 selected automatic records retain their original output hashes and rule objects. Thirteen coverage definitions are executable;76 remain narrative and require interpretation review. All89 primary quotations match the captured text. T1/T4pass qualitative organizer expectations;T2/T3/T5remain partial. No failed-status record is injected. Geographic matches are Census/TIGER-derived matches and are not a measured accuracy percentage. The selected records were generated by recorded tool-free Codex CLI calls and selected unchanged after AI-assisted source review. No independent legal review is claimed. Buyer, API offering, pilot and pricing are hypotheses, not current customers or validated demand. No claim of organizational endorsement from Studieren ohne Grenzen. Exact quotations support review; they do not certify interpretation. Public demo: https://yatrinn.github.io/lawdiff/ . Public repository: https://github.com/yatrinn/lawdiff .</a:t>
+              <a:t>Sources: public/data/rule-pack.json, public/data/catalog.json and public/data/corpus-coverage.json, checked together for the October 4, 2026 build. 133 selected automatic records retain the original recorded output hashes and unchanged rule objects. 22 coverage definitions are executable; 111 retain narrative scope and require interpretation review. The shared validator checks 133 exact quotation spans against captured text. Qualitative cases: T1 PASS, T2 PARTIAL, T3 PARTIAL, T4 PASS, T5 PARTIAL. Those are internal comparisons with supplied expectations, not jury scores. Census evidence establishes a legal city for 491 of 500 addresses through address interpolation or strict agreement of all returned official jurisdictions. It does not certify a parcel or establish an accuracy percentage. The records come from completed, recorded, tool-free Codex CLI calls and explicit unchanged selection after AI-assisted source review. No independent legal review is claimed. Buyer, API offering, pilot and pricing are hypotheses, not current customers or validated demand. No organizational endorsement from Studieren ohne Grenzen is claimed. Exact quotations support review, not legal certification. Public demo: https://yatrinn.github.io/lawdiff/ . Repository: https://github.com/yatrinn/lawdiff .</a:t>
             </a:r>
           </a:p>
         </p:txBody>
@@ -681,7 +681,7 @@
   </p:cSld>
   <p:clrMap bg1="lt1" tx1="dk1" bg2="lt2" tx2="dk2" accent1="accent1" accent2="accent2" accent3="accent3" accent4="accent4" accent5="accent5" accent6="accent6" hlink="hlink" folHlink="folHlink"/>
   <p:sldLayoutIdLst>
-    <p:sldLayoutId xmlns:r="http://schemas.openxmlformats.org/officeDocument/2006/relationships" id="2147483649" r:id="R6e8f3472cb5747c5"/>
+    <p:sldLayoutId xmlns:r="http://schemas.openxmlformats.org/officeDocument/2006/relationships" id="2147483649" r:id="R1de9b843087949c6"/>
   </p:sldLayoutIdLst>
   <p:txStyles>
     <p:titleStyle>
@@ -4477,7 +4477,7 @@
           <p:cNvPr id="20" name="text">
             <a:extLst xmlns:a="http://schemas.openxmlformats.org/drawingml/2006/main">
               <a:ext uri="{FF2B5EF4-FFF2-40B4-BE49-F238E27FC236}">
-                <a16:creationId xmlns:a16="http://schemas.microsoft.com/office/drawing/2014/main" id="{C73048A2-8DF2-4E3C-AB83-C3FD4B1DA6D0}"/>
+                <a16:creationId xmlns:a16="http://schemas.microsoft.com/office/drawing/2014/main" id="{8238DAB1-1B19-4D09-A87A-50E02ECF705E}"/>
               </a:ext>
             </a:extLst>
           </p:cNvPr>
@@ -4534,7 +4534,7 @@
           <p:cNvPr id="2" name="text">
             <a:extLst xmlns:a="http://schemas.openxmlformats.org/drawingml/2006/main">
               <a:ext uri="{FF2B5EF4-FFF2-40B4-BE49-F238E27FC236}">
-                <a16:creationId xmlns:a16="http://schemas.microsoft.com/office/drawing/2014/main" id="{4C4397C6-2B1A-46E2-9322-70DFA35208FC}"/>
+                <a16:creationId xmlns:a16="http://schemas.microsoft.com/office/drawing/2014/main" id="{0461772F-EBC7-4AFA-B4C6-E4A431359806}"/>
               </a:ext>
             </a:extLst>
           </p:cNvPr>
@@ -4591,7 +4591,7 @@
           <p:cNvPr id="3" name="text">
             <a:extLst xmlns:a="http://schemas.openxmlformats.org/drawingml/2006/main">
               <a:ext uri="{FF2B5EF4-FFF2-40B4-BE49-F238E27FC236}">
-                <a16:creationId xmlns:a16="http://schemas.microsoft.com/office/drawing/2014/main" id="{AC472C79-4A6E-4500-BC6B-C4F497A1CEC6}"/>
+                <a16:creationId xmlns:a16="http://schemas.microsoft.com/office/drawing/2014/main" id="{BBE9D3B0-01AF-40D6-8C0B-434DF31F6952}"/>
               </a:ext>
             </a:extLst>
           </p:cNvPr>
@@ -4648,7 +4648,7 @@
           <p:cNvPr id="4" name="main-title">
             <a:extLst xmlns:a="http://schemas.openxmlformats.org/drawingml/2006/main">
               <a:ext uri="{FF2B5EF4-FFF2-40B4-BE49-F238E27FC236}">
-                <a16:creationId xmlns:a16="http://schemas.microsoft.com/office/drawing/2014/main" id="{5315D7EA-D901-445A-A2A4-3D7997A3F934}"/>
+                <a16:creationId xmlns:a16="http://schemas.microsoft.com/office/drawing/2014/main" id="{422ADA89-7240-4CC5-9DFA-C1D25676705A}"/>
               </a:ext>
             </a:extLst>
           </p:cNvPr>
@@ -4728,7 +4728,7 @@
           <p:cNvPr id="5" name="text">
             <a:extLst xmlns:a="http://schemas.openxmlformats.org/drawingml/2006/main">
               <a:ext uri="{FF2B5EF4-FFF2-40B4-BE49-F238E27FC236}">
-                <a16:creationId xmlns:a16="http://schemas.microsoft.com/office/drawing/2014/main" id="{ED1BC634-6850-45AE-9F61-6EB8938C1B9E}"/>
+                <a16:creationId xmlns:a16="http://schemas.microsoft.com/office/drawing/2014/main" id="{25A75149-C6DF-4B65-8F03-679B3EF23222}"/>
               </a:ext>
             </a:extLst>
           </p:cNvPr>
@@ -4785,7 +4785,7 @@
           <p:cNvPr id="6" name="text">
             <a:extLst xmlns:a="http://schemas.openxmlformats.org/drawingml/2006/main">
               <a:ext uri="{FF2B5EF4-FFF2-40B4-BE49-F238E27FC236}">
-                <a16:creationId xmlns:a16="http://schemas.microsoft.com/office/drawing/2014/main" id="{00D11EDA-9D22-4DC7-871F-FC6CA8246E56}"/>
+                <a16:creationId xmlns:a16="http://schemas.microsoft.com/office/drawing/2014/main" id="{308B0F66-5766-4B0A-9A7F-F7CECB9BEDB1}"/>
               </a:ext>
             </a:extLst>
           </p:cNvPr>
@@ -4842,7 +4842,7 @@
           <p:cNvPr id="7" name="text">
             <a:extLst xmlns:a="http://schemas.openxmlformats.org/drawingml/2006/main">
               <a:ext uri="{FF2B5EF4-FFF2-40B4-BE49-F238E27FC236}">
-                <a16:creationId xmlns:a16="http://schemas.microsoft.com/office/drawing/2014/main" id="{05FD45C5-1E73-41E6-8218-716D881D5B33}"/>
+                <a16:creationId xmlns:a16="http://schemas.microsoft.com/office/drawing/2014/main" id="{4ABCEB5F-3726-4DB1-844A-6C1DA88297B5}"/>
               </a:ext>
             </a:extLst>
           </p:cNvPr>
@@ -4922,7 +4922,7 @@
           <p:cNvPr id="8" name="text">
             <a:extLst xmlns:a="http://schemas.openxmlformats.org/drawingml/2006/main">
               <a:ext uri="{FF2B5EF4-FFF2-40B4-BE49-F238E27FC236}">
-                <a16:creationId xmlns:a16="http://schemas.microsoft.com/office/drawing/2014/main" id="{79DF8DF4-EA77-4C4B-8AEE-A0B4885580E2}"/>
+                <a16:creationId xmlns:a16="http://schemas.microsoft.com/office/drawing/2014/main" id="{4E68A696-A564-4276-970D-020981D0E03A}"/>
               </a:ext>
             </a:extLst>
           </p:cNvPr>
@@ -4986,7 +4986,7 @@
         </p:xfrm>
         <a:graphic xmlns:a="http://schemas.openxmlformats.org/drawingml/2006/main">
           <a:graphicData uri="http://schemas.openxmlformats.org/drawingml/2006/chart">
-            <c:chart xmlns:r="http://schemas.openxmlformats.org/officeDocument/2006/relationships" xmlns:c="http://schemas.openxmlformats.org/drawingml/2006/chart" r:id="Rb318a5308283490d"/>
+            <c:chart xmlns:r="http://schemas.openxmlformats.org/officeDocument/2006/relationships" xmlns:c="http://schemas.openxmlformats.org/drawingml/2006/chart" r:id="R862c00bcc704450e"/>
           </a:graphicData>
         </a:graphic>
       </p:graphicFrame>
@@ -4995,7 +4995,7 @@
           <p:cNvPr id="10" name="text">
             <a:extLst xmlns:a="http://schemas.openxmlformats.org/drawingml/2006/main">
               <a:ext uri="{FF2B5EF4-FFF2-40B4-BE49-F238E27FC236}">
-                <a16:creationId xmlns:a16="http://schemas.microsoft.com/office/drawing/2014/main" id="{282228DD-3BF3-42AB-A1E7-CFBE4B051360}"/>
+                <a16:creationId xmlns:a16="http://schemas.microsoft.com/office/drawing/2014/main" id="{17512EA9-F546-45F5-81AD-A9395F052C56}"/>
               </a:ext>
             </a:extLst>
           </p:cNvPr>
@@ -5052,7 +5052,7 @@
           <p:cNvPr id="11" name="text">
             <a:extLst xmlns:a="http://schemas.openxmlformats.org/drawingml/2006/main">
               <a:ext uri="{FF2B5EF4-FFF2-40B4-BE49-F238E27FC236}">
-                <a16:creationId xmlns:a16="http://schemas.microsoft.com/office/drawing/2014/main" id="{556F10DC-C831-4FD2-849B-A76DD9093C68}"/>
+                <a16:creationId xmlns:a16="http://schemas.microsoft.com/office/drawing/2014/main" id="{CA842FAB-0FE2-455D-9381-B5B94B812E63}"/>
               </a:ext>
             </a:extLst>
           </p:cNvPr>
@@ -5109,7 +5109,7 @@
           <p:cNvPr id="12" name="text">
             <a:extLst xmlns:a="http://schemas.openxmlformats.org/drawingml/2006/main">
               <a:ext uri="{FF2B5EF4-FFF2-40B4-BE49-F238E27FC236}">
-                <a16:creationId xmlns:a16="http://schemas.microsoft.com/office/drawing/2014/main" id="{5E39CE0B-CD41-44EC-86C6-EFE9DE4BBE23}"/>
+                <a16:creationId xmlns:a16="http://schemas.microsoft.com/office/drawing/2014/main" id="{E381FA4F-7886-45E9-9DD7-76AE9A150B1E}"/>
               </a:ext>
             </a:extLst>
           </p:cNvPr>
@@ -5166,7 +5166,7 @@
           <p:cNvPr id="13" name="text">
             <a:extLst xmlns:a="http://schemas.openxmlformats.org/drawingml/2006/main">
               <a:ext uri="{FF2B5EF4-FFF2-40B4-BE49-F238E27FC236}">
-                <a16:creationId xmlns:a16="http://schemas.microsoft.com/office/drawing/2014/main" id="{EB924975-2BAA-4E8A-8B7D-07BF28F3D790}"/>
+                <a16:creationId xmlns:a16="http://schemas.microsoft.com/office/drawing/2014/main" id="{5C2E8F4D-60D5-4B9F-B0C6-632756F6CC82}"/>
               </a:ext>
             </a:extLst>
           </p:cNvPr>
@@ -5223,7 +5223,7 @@
           <p:cNvPr id="14" name="text">
             <a:extLst xmlns:a="http://schemas.openxmlformats.org/drawingml/2006/main">
               <a:ext uri="{FF2B5EF4-FFF2-40B4-BE49-F238E27FC236}">
-                <a16:creationId xmlns:a16="http://schemas.microsoft.com/office/drawing/2014/main" id="{8E366DE3-5DC6-4B4F-A140-C9C9298B27EA}"/>
+                <a16:creationId xmlns:a16="http://schemas.microsoft.com/office/drawing/2014/main" id="{657764FE-7450-482B-82B6-6177D12E5DAE}"/>
               </a:ext>
             </a:extLst>
           </p:cNvPr>
@@ -5280,7 +5280,7 @@
           <p:cNvPr id="15" name="text">
             <a:extLst xmlns:a="http://schemas.openxmlformats.org/drawingml/2006/main">
               <a:ext uri="{FF2B5EF4-FFF2-40B4-BE49-F238E27FC236}">
-                <a16:creationId xmlns:a16="http://schemas.microsoft.com/office/drawing/2014/main" id="{2A23A450-3E14-47E4-8191-C9656625BBF3}"/>
+                <a16:creationId xmlns:a16="http://schemas.microsoft.com/office/drawing/2014/main" id="{DFC02EA6-012E-46C8-8F81-927491C4DE81}"/>
               </a:ext>
             </a:extLst>
           </p:cNvPr>
@@ -5337,7 +5337,7 @@
           <p:cNvPr id="16" name="text">
             <a:extLst xmlns:a="http://schemas.openxmlformats.org/drawingml/2006/main">
               <a:ext uri="{FF2B5EF4-FFF2-40B4-BE49-F238E27FC236}">
-                <a16:creationId xmlns:a16="http://schemas.microsoft.com/office/drawing/2014/main" id="{F483628F-91C7-4142-8764-8E58420CB0A0}"/>
+                <a16:creationId xmlns:a16="http://schemas.microsoft.com/office/drawing/2014/main" id="{5D47AC7E-EB8E-43F7-B01F-5360A5C9E397}"/>
               </a:ext>
             </a:extLst>
           </p:cNvPr>
@@ -5444,7 +5444,7 @@
           <p:cNvPr id="19" name="text">
             <a:extLst xmlns:a="http://schemas.openxmlformats.org/drawingml/2006/main">
               <a:ext uri="{FF2B5EF4-FFF2-40B4-BE49-F238E27FC236}">
-                <a16:creationId xmlns:a16="http://schemas.microsoft.com/office/drawing/2014/main" id="{EFAAA08A-8919-4E9F-A23F-131D3964220A}"/>
+                <a16:creationId xmlns:a16="http://schemas.microsoft.com/office/drawing/2014/main" id="{97D91244-3DBE-4C72-8085-500CC927A8EF}"/>
               </a:ext>
             </a:extLst>
           </p:cNvPr>
@@ -5499,7 +5499,7 @@
     </p:spTree>
     <p:extLst>
       <p:ext uri="{BB962C8B-B14F-4D97-AF65-F5344CB8AC3E}">
-        <p14:creationId xmlns:p14="http://schemas.microsoft.com/office/powerpoint/2010/main" val="356139482"/>
+        <p14:creationId xmlns:p14="http://schemas.microsoft.com/office/powerpoint/2010/main" val="688364371"/>
       </p:ext>
     </p:extLst>
   </p:cSld>
@@ -5530,7 +5530,7 @@
           <p:cNvPr id="33" name="text">
             <a:extLst xmlns:a="http://schemas.openxmlformats.org/drawingml/2006/main">
               <a:ext uri="{FF2B5EF4-FFF2-40B4-BE49-F238E27FC236}">
-                <a16:creationId xmlns:a16="http://schemas.microsoft.com/office/drawing/2014/main" id="{EF7CACAB-6946-45F9-A656-6FA144EB16C8}"/>
+                <a16:creationId xmlns:a16="http://schemas.microsoft.com/office/drawing/2014/main" id="{594B698C-D293-4916-A683-B74A5DB43834}"/>
               </a:ext>
             </a:extLst>
           </p:cNvPr>
@@ -5587,7 +5587,7 @@
           <p:cNvPr id="2" name="text">
             <a:extLst xmlns:a="http://schemas.openxmlformats.org/drawingml/2006/main">
               <a:ext uri="{FF2B5EF4-FFF2-40B4-BE49-F238E27FC236}">
-                <a16:creationId xmlns:a16="http://schemas.microsoft.com/office/drawing/2014/main" id="{0ECF3D50-F7B5-4849-9BEA-FD65F103349A}"/>
+                <a16:creationId xmlns:a16="http://schemas.microsoft.com/office/drawing/2014/main" id="{FE93CA1C-3B93-4985-AF3A-E530AF810A71}"/>
               </a:ext>
             </a:extLst>
           </p:cNvPr>
@@ -5644,7 +5644,7 @@
           <p:cNvPr id="3" name="text">
             <a:extLst xmlns:a="http://schemas.openxmlformats.org/drawingml/2006/main">
               <a:ext uri="{FF2B5EF4-FFF2-40B4-BE49-F238E27FC236}">
-                <a16:creationId xmlns:a16="http://schemas.microsoft.com/office/drawing/2014/main" id="{2E647862-F4D0-4BBF-88CF-628376083959}"/>
+                <a16:creationId xmlns:a16="http://schemas.microsoft.com/office/drawing/2014/main" id="{0AF03F6C-5D04-489F-85D9-76601C939FB7}"/>
               </a:ext>
             </a:extLst>
           </p:cNvPr>
@@ -5701,7 +5701,7 @@
           <p:cNvPr id="4" name="main-title">
             <a:extLst xmlns:a="http://schemas.openxmlformats.org/drawingml/2006/main">
               <a:ext uri="{FF2B5EF4-FFF2-40B4-BE49-F238E27FC236}">
-                <a16:creationId xmlns:a16="http://schemas.microsoft.com/office/drawing/2014/main" id="{65B45820-94D7-42E7-BDDA-CEF20DD1E1B7}"/>
+                <a16:creationId xmlns:a16="http://schemas.microsoft.com/office/drawing/2014/main" id="{1939ADE3-75A0-4D9B-9B05-80475C6CAB48}"/>
               </a:ext>
             </a:extLst>
           </p:cNvPr>
@@ -5748,7 +5748,7 @@
                 <a:ea typeface="Helvetica Neue"/>
                 <a:cs typeface="Helvetica Neue"/>
               </a:rPr>
-              <a:t>From legal text to</a:t>
+              <a:t>Legal text.</a:t>
             </a:r>
           </a:p>
           <a:p xmlns:a="http://schemas.openxmlformats.org/drawingml/2006/main">
@@ -5771,7 +5771,7 @@
                 <a:ea typeface="Helvetica Neue"/>
                 <a:cs typeface="Helvetica Neue"/>
               </a:rPr>
-              <a:t>reviewable decisions.</a:t>
+              <a:t>Reviewable decisions.</a:t>
             </a:r>
           </a:p>
         </p:txBody>
@@ -5781,7 +5781,7 @@
           <p:cNvPr id="5" name="text">
             <a:extLst xmlns:a="http://schemas.openxmlformats.org/drawingml/2006/main">
               <a:ext uri="{FF2B5EF4-FFF2-40B4-BE49-F238E27FC236}">
-                <a16:creationId xmlns:a16="http://schemas.microsoft.com/office/drawing/2014/main" id="{9777C886-90F4-4C45-8C11-54951A18F958}"/>
+                <a16:creationId xmlns:a16="http://schemas.microsoft.com/office/drawing/2014/main" id="{A1A3DF2E-DAF3-4A85-B47E-BC28929D5746}"/>
               </a:ext>
             </a:extLst>
           </p:cNvPr>
@@ -5838,7 +5838,7 @@
           <p:cNvPr id="6" name="text">
             <a:extLst xmlns:a="http://schemas.openxmlformats.org/drawingml/2006/main">
               <a:ext uri="{FF2B5EF4-FFF2-40B4-BE49-F238E27FC236}">
-                <a16:creationId xmlns:a16="http://schemas.microsoft.com/office/drawing/2014/main" id="{C36CD957-28C8-4339-ADDC-040B41D94D24}"/>
+                <a16:creationId xmlns:a16="http://schemas.microsoft.com/office/drawing/2014/main" id="{15F70E0E-09FC-44B2-BFFB-3656535F68B5}"/>
               </a:ext>
             </a:extLst>
           </p:cNvPr>
@@ -5895,7 +5895,7 @@
           <p:cNvPr id="7" name="text">
             <a:extLst xmlns:a="http://schemas.openxmlformats.org/drawingml/2006/main">
               <a:ext uri="{FF2B5EF4-FFF2-40B4-BE49-F238E27FC236}">
-                <a16:creationId xmlns:a16="http://schemas.microsoft.com/office/drawing/2014/main" id="{259006E4-FE06-4D5E-B513-04F39ADB465F}"/>
+                <a16:creationId xmlns:a16="http://schemas.microsoft.com/office/drawing/2014/main" id="{4D0DAB12-503A-47C6-B3C1-EAE80D2B2E41}"/>
               </a:ext>
             </a:extLst>
           </p:cNvPr>
@@ -5952,7 +5952,7 @@
           <p:cNvPr id="8" name="text">
             <a:extLst xmlns:a="http://schemas.openxmlformats.org/drawingml/2006/main">
               <a:ext uri="{FF2B5EF4-FFF2-40B4-BE49-F238E27FC236}">
-                <a16:creationId xmlns:a16="http://schemas.microsoft.com/office/drawing/2014/main" id="{599FB0D5-DEDB-46E7-8B38-8889E1937802}"/>
+                <a16:creationId xmlns:a16="http://schemas.microsoft.com/office/drawing/2014/main" id="{901F0FE9-5A83-4D47-A2FA-0D9347BF997B}"/>
               </a:ext>
             </a:extLst>
           </p:cNvPr>
@@ -6009,7 +6009,7 @@
           <p:cNvPr id="9" name="text">
             <a:extLst xmlns:a="http://schemas.openxmlformats.org/drawingml/2006/main">
               <a:ext uri="{FF2B5EF4-FFF2-40B4-BE49-F238E27FC236}">
-                <a16:creationId xmlns:a16="http://schemas.microsoft.com/office/drawing/2014/main" id="{18B7726E-84FE-4E82-A35E-B079CD0DFF86}"/>
+                <a16:creationId xmlns:a16="http://schemas.microsoft.com/office/drawing/2014/main" id="{28D7E317-1991-4A52-87A4-394916C83D04}"/>
               </a:ext>
             </a:extLst>
           </p:cNvPr>
@@ -6066,7 +6066,7 @@
           <p:cNvPr id="10" name="text">
             <a:extLst xmlns:a="http://schemas.openxmlformats.org/drawingml/2006/main">
               <a:ext uri="{FF2B5EF4-FFF2-40B4-BE49-F238E27FC236}">
-                <a16:creationId xmlns:a16="http://schemas.microsoft.com/office/drawing/2014/main" id="{F1229D03-6A5E-41D1-8530-60EBE6EDEE66}"/>
+                <a16:creationId xmlns:a16="http://schemas.microsoft.com/office/drawing/2014/main" id="{FEB76BF7-D58F-4CDF-865A-CDDB80201446}"/>
               </a:ext>
             </a:extLst>
           </p:cNvPr>
@@ -6113,7 +6113,7 @@
                 <a:ea typeface="Helvetica Neue"/>
                 <a:cs typeface="Helvetica Neue"/>
               </a:rPr>
-              <a:t>Automatic + source review</a:t>
+              <a:t>Automatic + AI source review</a:t>
             </a:r>
           </a:p>
         </p:txBody>
@@ -6123,7 +6123,7 @@
           <p:cNvPr id="11" name="text">
             <a:extLst xmlns:a="http://schemas.openxmlformats.org/drawingml/2006/main">
               <a:ext uri="{FF2B5EF4-FFF2-40B4-BE49-F238E27FC236}">
-                <a16:creationId xmlns:a16="http://schemas.microsoft.com/office/drawing/2014/main" id="{1D9DBCBE-DA98-4014-8D29-CB28CFAFD038}"/>
+                <a16:creationId xmlns:a16="http://schemas.microsoft.com/office/drawing/2014/main" id="{A9CC8B22-30AE-45F9-9017-0EF954BDE066}"/>
               </a:ext>
             </a:extLst>
           </p:cNvPr>
@@ -6180,7 +6180,7 @@
           <p:cNvPr id="12" name="text">
             <a:extLst xmlns:a="http://schemas.openxmlformats.org/drawingml/2006/main">
               <a:ext uri="{FF2B5EF4-FFF2-40B4-BE49-F238E27FC236}">
-                <a16:creationId xmlns:a16="http://schemas.microsoft.com/office/drawing/2014/main" id="{F257DE52-F622-4FFE-9905-59DB632A39F7}"/>
+                <a16:creationId xmlns:a16="http://schemas.microsoft.com/office/drawing/2014/main" id="{23EBEDE9-D1BC-4147-9D16-1E1E30E8E920}"/>
               </a:ext>
             </a:extLst>
           </p:cNvPr>
@@ -6237,7 +6237,7 @@
           <p:cNvPr id="13" name="text">
             <a:extLst xmlns:a="http://schemas.openxmlformats.org/drawingml/2006/main">
               <a:ext uri="{FF2B5EF4-FFF2-40B4-BE49-F238E27FC236}">
-                <a16:creationId xmlns:a16="http://schemas.microsoft.com/office/drawing/2014/main" id="{829FDCC0-9ED2-4054-ABA9-2E84805A9797}"/>
+                <a16:creationId xmlns:a16="http://schemas.microsoft.com/office/drawing/2014/main" id="{CF19B536-D1FF-4995-BB12-D334890D17EE}"/>
               </a:ext>
             </a:extLst>
           </p:cNvPr>
@@ -6294,7 +6294,7 @@
           <p:cNvPr id="14" name="text">
             <a:extLst xmlns:a="http://schemas.openxmlformats.org/drawingml/2006/main">
               <a:ext uri="{FF2B5EF4-FFF2-40B4-BE49-F238E27FC236}">
-                <a16:creationId xmlns:a16="http://schemas.microsoft.com/office/drawing/2014/main" id="{401A55E7-8EA5-49B2-9C1B-4F383420B69E}"/>
+                <a16:creationId xmlns:a16="http://schemas.microsoft.com/office/drawing/2014/main" id="{83E4EF07-9D3D-4167-BECE-3875C51C0B51}"/>
               </a:ext>
             </a:extLst>
           </p:cNvPr>
@@ -6351,7 +6351,7 @@
           <p:cNvPr id="15" name="text">
             <a:extLst xmlns:a="http://schemas.openxmlformats.org/drawingml/2006/main">
               <a:ext uri="{FF2B5EF4-FFF2-40B4-BE49-F238E27FC236}">
-                <a16:creationId xmlns:a16="http://schemas.microsoft.com/office/drawing/2014/main" id="{CA1EE214-B021-40CB-AC18-D49CB4C82CBB}"/>
+                <a16:creationId xmlns:a16="http://schemas.microsoft.com/office/drawing/2014/main" id="{9A062A97-C2A8-4972-875B-16B73B0B3AB8}"/>
               </a:ext>
             </a:extLst>
           </p:cNvPr>
@@ -6408,7 +6408,7 @@
           <p:cNvPr id="16" name="text">
             <a:extLst xmlns:a="http://schemas.openxmlformats.org/drawingml/2006/main">
               <a:ext uri="{FF2B5EF4-FFF2-40B4-BE49-F238E27FC236}">
-                <a16:creationId xmlns:a16="http://schemas.microsoft.com/office/drawing/2014/main" id="{97F02057-E718-4F57-99B3-AC03B9695F1B}"/>
+                <a16:creationId xmlns:a16="http://schemas.microsoft.com/office/drawing/2014/main" id="{3BE9B3C9-D407-4C0D-88F2-BF8438ED4B27}"/>
               </a:ext>
             </a:extLst>
           </p:cNvPr>
@@ -6540,7 +6540,7 @@
           <p:cNvPr id="20" name="text">
             <a:extLst xmlns:a="http://schemas.openxmlformats.org/drawingml/2006/main">
               <a:ext uri="{FF2B5EF4-FFF2-40B4-BE49-F238E27FC236}">
-                <a16:creationId xmlns:a16="http://schemas.microsoft.com/office/drawing/2014/main" id="{F70210AD-2886-458A-BCFB-41CE98083E05}"/>
+                <a16:creationId xmlns:a16="http://schemas.microsoft.com/office/drawing/2014/main" id="{304BEE06-7A7A-4080-817F-7527F8F97E24}"/>
               </a:ext>
             </a:extLst>
           </p:cNvPr>
@@ -6587,7 +6587,7 @@
                 <a:ea typeface="Helvetica Neue"/>
                 <a:cs typeface="Helvetica Neue"/>
               </a:rPr>
-              <a:t>89</a:t>
+              <a:t>133</a:t>
             </a:r>
           </a:p>
         </p:txBody>
@@ -6597,7 +6597,7 @@
           <p:cNvPr id="21" name="text">
             <a:extLst xmlns:a="http://schemas.openxmlformats.org/drawingml/2006/main">
               <a:ext uri="{FF2B5EF4-FFF2-40B4-BE49-F238E27FC236}">
-                <a16:creationId xmlns:a16="http://schemas.microsoft.com/office/drawing/2014/main" id="{6817118C-52D6-4C7D-9F0D-C96C34B3F928}"/>
+                <a16:creationId xmlns:a16="http://schemas.microsoft.com/office/drawing/2014/main" id="{01A23A72-6E5F-4DB3-AED8-3570649A31BD}"/>
               </a:ext>
             </a:extLst>
           </p:cNvPr>
@@ -6644,7 +6644,7 @@
                 <a:ea typeface="Helvetica Neue"/>
                 <a:cs typeface="Helvetica Neue"/>
               </a:rPr>
-              <a:t>selected rule records</a:t>
+              <a:t>selected automatic records</a:t>
             </a:r>
           </a:p>
         </p:txBody>
@@ -6654,7 +6654,7 @@
           <p:cNvPr id="22" name="text">
             <a:extLst xmlns:a="http://schemas.openxmlformats.org/drawingml/2006/main">
               <a:ext uri="{FF2B5EF4-FFF2-40B4-BE49-F238E27FC236}">
-                <a16:creationId xmlns:a16="http://schemas.microsoft.com/office/drawing/2014/main" id="{426A8454-1576-4A35-A2C3-405D4B61AFE1}"/>
+                <a16:creationId xmlns:a16="http://schemas.microsoft.com/office/drawing/2014/main" id="{BD2CBC13-D187-4CC3-A435-1BF7B80B21DD}"/>
               </a:ext>
             </a:extLst>
           </p:cNvPr>
@@ -6701,7 +6701,7 @@
                 <a:ea typeface="Helvetica Neue"/>
                 <a:cs typeface="Helvetica Neue"/>
               </a:rPr>
-              <a:t>13</a:t>
+              <a:t>22</a:t>
             </a:r>
           </a:p>
         </p:txBody>
@@ -6711,7 +6711,7 @@
           <p:cNvPr id="23" name="text">
             <a:extLst xmlns:a="http://schemas.openxmlformats.org/drawingml/2006/main">
               <a:ext uri="{FF2B5EF4-FFF2-40B4-BE49-F238E27FC236}">
-                <a16:creationId xmlns:a16="http://schemas.microsoft.com/office/drawing/2014/main" id="{F369DFAB-EA0F-4622-86CE-D892588FCB39}"/>
+                <a16:creationId xmlns:a16="http://schemas.microsoft.com/office/drawing/2014/main" id="{27DA63D3-822A-4A3C-A3D1-5849A2B8A8BF}"/>
               </a:ext>
             </a:extLst>
           </p:cNvPr>
@@ -6758,7 +6758,7 @@
                 <a:ea typeface="Helvetica Neue"/>
                 <a:cs typeface="Helvetica Neue"/>
               </a:rPr>
-              <a:t>executable coverage</a:t>
+              <a:t>executable conditions</a:t>
             </a:r>
           </a:p>
         </p:txBody>
@@ -6768,7 +6768,7 @@
           <p:cNvPr id="24" name="text">
             <a:extLst xmlns:a="http://schemas.openxmlformats.org/drawingml/2006/main">
               <a:ext uri="{FF2B5EF4-FFF2-40B4-BE49-F238E27FC236}">
-                <a16:creationId xmlns:a16="http://schemas.microsoft.com/office/drawing/2014/main" id="{C1B17FD6-479C-407A-B869-709A6B37DF79}"/>
+                <a16:creationId xmlns:a16="http://schemas.microsoft.com/office/drawing/2014/main" id="{87622086-09E5-4B1D-B75B-54C23BC2A8F1}"/>
               </a:ext>
             </a:extLst>
           </p:cNvPr>
@@ -6815,7 +6815,7 @@
                 <a:ea typeface="Helvetica Neue"/>
                 <a:cs typeface="Helvetica Neue"/>
               </a:rPr>
-              <a:t>475/500</a:t>
+              <a:t>491/500</a:t>
             </a:r>
           </a:p>
         </p:txBody>
@@ -6825,7 +6825,7 @@
           <p:cNvPr id="25" name="text">
             <a:extLst xmlns:a="http://schemas.openxmlformats.org/drawingml/2006/main">
               <a:ext uri="{FF2B5EF4-FFF2-40B4-BE49-F238E27FC236}">
-                <a16:creationId xmlns:a16="http://schemas.microsoft.com/office/drawing/2014/main" id="{C71BBD63-A613-4D46-BCC6-08C2EA71AFA8}"/>
+                <a16:creationId xmlns:a16="http://schemas.microsoft.com/office/drawing/2014/main" id="{1F7ACEB1-A526-4282-976D-3FE5AFB8212D}"/>
               </a:ext>
             </a:extLst>
           </p:cNvPr>
@@ -6872,7 +6872,7 @@
                 <a:ea typeface="Helvetica Neue"/>
                 <a:cs typeface="Helvetica Neue"/>
               </a:rPr>
-              <a:t>geographic matches</a:t>
+              <a:t>Census legal-city matches</a:t>
             </a:r>
           </a:p>
         </p:txBody>
@@ -6882,7 +6882,7 @@
           <p:cNvPr id="26" name="text">
             <a:extLst xmlns:a="http://schemas.openxmlformats.org/drawingml/2006/main">
               <a:ext uri="{FF2B5EF4-FFF2-40B4-BE49-F238E27FC236}">
-                <a16:creationId xmlns:a16="http://schemas.microsoft.com/office/drawing/2014/main" id="{AD4E9D0E-304A-462E-B93E-4AA7F76D90D5}"/>
+                <a16:creationId xmlns:a16="http://schemas.microsoft.com/office/drawing/2014/main" id="{8D760478-2589-403E-A1F7-2EF7F64BA690}"/>
               </a:ext>
             </a:extLst>
           </p:cNvPr>
@@ -6952,7 +6952,7 @@
                 <a:ea typeface="Helvetica Neue"/>
                 <a:cs typeface="Helvetica Neue"/>
               </a:rPr>
-              <a:t>Counts do not measure legal accuracy.</a:t>
+              <a:t>111 records need scope interpretation. Counts are not accuracy.</a:t>
             </a:r>
           </a:p>
         </p:txBody>
@@ -6962,7 +6962,7 @@
           <p:cNvPr id="27" name="text">
             <a:extLst xmlns:a="http://schemas.openxmlformats.org/drawingml/2006/main">
               <a:ext uri="{FF2B5EF4-FFF2-40B4-BE49-F238E27FC236}">
-                <a16:creationId xmlns:a16="http://schemas.microsoft.com/office/drawing/2014/main" id="{3453297F-40C8-413B-8EAD-378C452F22B5}"/>
+                <a16:creationId xmlns:a16="http://schemas.microsoft.com/office/drawing/2014/main" id="{A18815AC-A51F-4D64-9A7E-93A0AF76C37F}"/>
               </a:ext>
             </a:extLst>
           </p:cNvPr>
@@ -7019,7 +7019,7 @@
           <p:cNvPr id="28" name="text">
             <a:extLst xmlns:a="http://schemas.openxmlformats.org/drawingml/2006/main">
               <a:ext uri="{FF2B5EF4-FFF2-40B4-BE49-F238E27FC236}">
-                <a16:creationId xmlns:a16="http://schemas.microsoft.com/office/drawing/2014/main" id="{1D3F7C6A-CDD1-46E1-ABD3-730A47E89A9A}"/>
+                <a16:creationId xmlns:a16="http://schemas.microsoft.com/office/drawing/2014/main" id="{60EC4766-1E90-47D9-8904-ABFBED5986CA}"/>
               </a:ext>
             </a:extLst>
           </p:cNvPr>
@@ -7076,7 +7076,7 @@
           <p:cNvPr id="29" name="text">
             <a:extLst xmlns:a="http://schemas.openxmlformats.org/drawingml/2006/main">
               <a:ext uri="{FF2B5EF4-FFF2-40B4-BE49-F238E27FC236}">
-                <a16:creationId xmlns:a16="http://schemas.microsoft.com/office/drawing/2014/main" id="{2F97D8CD-8671-43E0-8F08-BF5EC72E4197}"/>
+                <a16:creationId xmlns:a16="http://schemas.microsoft.com/office/drawing/2014/main" id="{7B2B28F0-A477-4306-852D-B07EA1E5AD4F}"/>
               </a:ext>
             </a:extLst>
           </p:cNvPr>
@@ -7123,7 +7123,7 @@
                 <a:ea typeface="Helvetica Neue"/>
                 <a:cs typeface="Helvetica Neue"/>
               </a:rPr>
-              <a:t>Change → evidence → review</a:t>
+              <a:t>Evidence and review brief</a:t>
             </a:r>
           </a:p>
           <a:p xmlns:a="http://schemas.openxmlformats.org/drawingml/2006/main">
@@ -7156,7 +7156,7 @@
           <p:cNvPr id="30" name="text">
             <a:extLst xmlns:a="http://schemas.openxmlformats.org/drawingml/2006/main">
               <a:ext uri="{FF2B5EF4-FFF2-40B4-BE49-F238E27FC236}">
-                <a16:creationId xmlns:a16="http://schemas.microsoft.com/office/drawing/2014/main" id="{C7B6694B-9139-4B0F-B5D6-ECC40884AD8D}"/>
+                <a16:creationId xmlns:a16="http://schemas.microsoft.com/office/drawing/2014/main" id="{4243F4E1-2833-4EFC-972D-0A0B577DB9E0}"/>
               </a:ext>
             </a:extLst>
           </p:cNvPr>
@@ -7236,7 +7236,7 @@
           <p:cNvPr id="31" name="text">
             <a:extLst xmlns:a="http://schemas.openxmlformats.org/drawingml/2006/main">
               <a:ext uri="{FF2B5EF4-FFF2-40B4-BE49-F238E27FC236}">
-                <a16:creationId xmlns:a16="http://schemas.microsoft.com/office/drawing/2014/main" id="{EE4253B9-5BBB-4F18-8094-DC4218B4D416}"/>
+                <a16:creationId xmlns:a16="http://schemas.microsoft.com/office/drawing/2014/main" id="{56AA5632-128C-473B-9721-93CC7252E80F}"/>
               </a:ext>
             </a:extLst>
           </p:cNvPr>
@@ -7293,7 +7293,7 @@
           <p:cNvPr id="32" name="text">
             <a:extLst xmlns:a="http://schemas.openxmlformats.org/drawingml/2006/main">
               <a:ext uri="{FF2B5EF4-FFF2-40B4-BE49-F238E27FC236}">
-                <a16:creationId xmlns:a16="http://schemas.microsoft.com/office/drawing/2014/main" id="{919BC6A1-2CC9-4237-A2D0-5378F3ED2A21}"/>
+                <a16:creationId xmlns:a16="http://schemas.microsoft.com/office/drawing/2014/main" id="{2CF1590B-CCFC-415F-8B5B-C0C79B3325F8}"/>
               </a:ext>
             </a:extLst>
           </p:cNvPr>
@@ -7348,7 +7348,7 @@
     </p:spTree>
     <p:extLst>
       <p:ext uri="{BB962C8B-B14F-4D97-AF65-F5344CB8AC3E}">
-        <p14:creationId xmlns:p14="http://schemas.microsoft.com/office/powerpoint/2010/main" val="1708594228"/>
+        <p14:creationId xmlns:p14="http://schemas.microsoft.com/office/powerpoint/2010/main" val="1586536765"/>
       </p:ext>
     </p:extLst>
   </p:cSld>

</xml_diff>